<commit_message>
Record real Groq boundaries and current continuation evidence
</commit_message>
<xml_diff>
--- a/docs/Alwaz-LeakShield-continued.pptx
+++ b/docs/Alwaz-LeakShield-continued.pptx
@@ -2,20 +2,20 @@
 <file path=ppt/presentation.xml><?xml version="1.0" encoding="utf-8"?>
 <p:presentation xmlns:p="http://schemas.openxmlformats.org/presentationml/2006/main">
   <p:sldMasterIdLst>
-    <p:sldMasterId xmlns:r="http://schemas.openxmlformats.org/officeDocument/2006/relationships" id="2147483648" r:id="R81ca0ea5908b4ede"/>
+    <p:sldMasterId xmlns:r="http://schemas.openxmlformats.org/officeDocument/2006/relationships" id="2147483648" r:id="R413fb88b096d4f49"/>
   </p:sldMasterIdLst>
   <p:notesMasterIdLst>
-    <p:notesMasterId xmlns:r="http://schemas.openxmlformats.org/officeDocument/2006/relationships" r:id="R13cfefe383f74c05"/>
+    <p:notesMasterId xmlns:r="http://schemas.openxmlformats.org/officeDocument/2006/relationships" r:id="R27b3dcd868f64357"/>
   </p:notesMasterIdLst>
   <p:sldIdLst>
-    <p:sldId xmlns:r="http://schemas.openxmlformats.org/officeDocument/2006/relationships" id="256" r:id="R161813e0fa854d96"/>
-    <p:sldId xmlns:r="http://schemas.openxmlformats.org/officeDocument/2006/relationships" id="257" r:id="R33f1132383f44035"/>
-    <p:sldId xmlns:r="http://schemas.openxmlformats.org/officeDocument/2006/relationships" id="258" r:id="Rd833234d840d4b3f"/>
-    <p:sldId xmlns:r="http://schemas.openxmlformats.org/officeDocument/2006/relationships" id="259" r:id="Rc76ce56ea3484d03"/>
-    <p:sldId xmlns:r="http://schemas.openxmlformats.org/officeDocument/2006/relationships" id="260" r:id="R5668c582be9a45b7"/>
-    <p:sldId xmlns:r="http://schemas.openxmlformats.org/officeDocument/2006/relationships" id="261" r:id="R30a9428267d84c35"/>
-    <p:sldId xmlns:r="http://schemas.openxmlformats.org/officeDocument/2006/relationships" id="262" r:id="Rbd9282473a134009"/>
-    <p:sldId xmlns:r="http://schemas.openxmlformats.org/officeDocument/2006/relationships" id="263" r:id="R665b40bb5ec7411b"/>
+    <p:sldId xmlns:r="http://schemas.openxmlformats.org/officeDocument/2006/relationships" id="256" r:id="R815ece5b1ac240bd"/>
+    <p:sldId xmlns:r="http://schemas.openxmlformats.org/officeDocument/2006/relationships" id="257" r:id="R4099f785033c4ea6"/>
+    <p:sldId xmlns:r="http://schemas.openxmlformats.org/officeDocument/2006/relationships" id="258" r:id="Rbef47338beba4e23"/>
+    <p:sldId xmlns:r="http://schemas.openxmlformats.org/officeDocument/2006/relationships" id="259" r:id="R904b2c1f10bd4282"/>
+    <p:sldId xmlns:r="http://schemas.openxmlformats.org/officeDocument/2006/relationships" id="260" r:id="Rbb9faedbe8e44782"/>
+    <p:sldId xmlns:r="http://schemas.openxmlformats.org/officeDocument/2006/relationships" id="261" r:id="R1ad48ef2ca724f1d"/>
+    <p:sldId xmlns:r="http://schemas.openxmlformats.org/officeDocument/2006/relationships" id="262" r:id="R98af184b6b524a86"/>
+    <p:sldId xmlns:r="http://schemas.openxmlformats.org/officeDocument/2006/relationships" id="263" r:id="Rbab70b3967a84994"/>
   </p:sldIdLst>
   <p:sldSz cx="12191695" cy="6858000"/>
   <p:notesSz cx="6858000" cy="9144000"/>
@@ -844,7 +844,7 @@
           <a:lstStyle xmlns:a="http://schemas.openxmlformats.org/drawingml/2006/main"/>
           <a:p xmlns:a="http://schemas.openxmlformats.org/drawingml/2006/main">
             <a:r>
-              <a:t>Source: results/alwaz/access-eval.json. Access-only fixtures are not detector precision/recall or full-team leak metrics.</a:t>
+              <a:t>Current validation: docs/ALWAZ-CONTINUATION.md; real Groq boundaries: results/continuation-groq/boundaries.json; historical Ollama labels: results/alwaz/ollama-verification.json. Current Groq smoke is unfrozen and is not a full model-backed evaluation.</a:t>
             </a:r>
           </a:p>
         </p:txBody>
@@ -1101,7 +1101,7 @@
           <p:cNvPr id="2" name="Title 1">
             <a:extLst xmlns:a="http://schemas.openxmlformats.org/drawingml/2006/main">
               <a:ext uri="{FF2B5EF4-FFF2-40B4-BE49-F238E27FC236}">
-                <a16:creationId xmlns:a16="http://schemas.microsoft.com/office/drawing/2014/main" id="{B2A75514-68A2-4E6F-A30A-FF2DC71B6208}"/>
+                <a16:creationId xmlns:a16="http://schemas.microsoft.com/office/drawing/2014/main" id="{253A8791-FDC4-4788-B94D-49D4D476760E}"/>
               </a:ext>
             </a:extLst>
           </p:cNvPr>
@@ -1134,7 +1134,7 @@
           <p:cNvPr id="3" name="Subtitle 2">
             <a:extLst xmlns:a="http://schemas.openxmlformats.org/drawingml/2006/main">
               <a:ext uri="{FF2B5EF4-FFF2-40B4-BE49-F238E27FC236}">
-                <a16:creationId xmlns:a16="http://schemas.microsoft.com/office/drawing/2014/main" id="{23250C20-3394-42DE-8222-6C14B3313907}"/>
+                <a16:creationId xmlns:a16="http://schemas.microsoft.com/office/drawing/2014/main" id="{2C48804C-8DD9-4102-A07B-A93432ADB67E}"/>
               </a:ext>
             </a:extLst>
           </p:cNvPr>
@@ -1258,7 +1258,7 @@
           <p:cNvPr id="4" name="Date Placeholder 3">
             <a:extLst xmlns:a="http://schemas.openxmlformats.org/drawingml/2006/main">
               <a:ext uri="{FF2B5EF4-FFF2-40B4-BE49-F238E27FC236}">
-                <a16:creationId xmlns:a16="http://schemas.microsoft.com/office/drawing/2014/main" id="{19877518-6435-4E1B-9F51-9C7139142D4D}"/>
+                <a16:creationId xmlns:a16="http://schemas.microsoft.com/office/drawing/2014/main" id="{5718E0BE-966A-41DA-BD11-375FD73E84C1}"/>
               </a:ext>
             </a:extLst>
           </p:cNvPr>
@@ -1286,7 +1286,7 @@
           <p:cNvPr id="5" name="Footer Placeholder 4">
             <a:extLst xmlns:a="http://schemas.openxmlformats.org/drawingml/2006/main">
               <a:ext uri="{FF2B5EF4-FFF2-40B4-BE49-F238E27FC236}">
-                <a16:creationId xmlns:a16="http://schemas.microsoft.com/office/drawing/2014/main" id="{D0658B9F-E5AA-4D6A-9575-5B94E356B58E}"/>
+                <a16:creationId xmlns:a16="http://schemas.microsoft.com/office/drawing/2014/main" id="{6BD185F6-B576-4161-91BC-DC9167253A5F}"/>
               </a:ext>
             </a:extLst>
           </p:cNvPr>
@@ -1311,7 +1311,7 @@
           <p:cNvPr id="6" name="Slide Number Placeholder 5">
             <a:extLst xmlns:a="http://schemas.openxmlformats.org/drawingml/2006/main">
               <a:ext uri="{FF2B5EF4-FFF2-40B4-BE49-F238E27FC236}">
-                <a16:creationId xmlns:a16="http://schemas.microsoft.com/office/drawing/2014/main" id="{B03013E9-4E68-4E11-B25A-664979E497EF}"/>
+                <a16:creationId xmlns:a16="http://schemas.microsoft.com/office/drawing/2014/main" id="{404EF204-3D66-4C26-9F61-1B896820B229}"/>
               </a:ext>
             </a:extLst>
           </p:cNvPr>
@@ -1356,7 +1356,7 @@
           <p:cNvPr id="2" name="Title 1">
             <a:extLst xmlns:a="http://schemas.openxmlformats.org/drawingml/2006/main">
               <a:ext uri="{FF2B5EF4-FFF2-40B4-BE49-F238E27FC236}">
-                <a16:creationId xmlns:a16="http://schemas.microsoft.com/office/drawing/2014/main" id="{1AF1C11A-ED51-40D4-9C69-C49D74A471E1}"/>
+                <a16:creationId xmlns:a16="http://schemas.microsoft.com/office/drawing/2014/main" id="{5AD3BB8F-CDA2-4A75-8FF0-4D5BED601C9E}"/>
               </a:ext>
             </a:extLst>
           </p:cNvPr>
@@ -1384,7 +1384,7 @@
           <p:cNvPr id="3" name="Vertical Text Placeholder 2">
             <a:extLst xmlns:a="http://schemas.openxmlformats.org/drawingml/2006/main">
               <a:ext uri="{FF2B5EF4-FFF2-40B4-BE49-F238E27FC236}">
-                <a16:creationId xmlns:a16="http://schemas.microsoft.com/office/drawing/2014/main" id="{BE6CA451-10C0-43B3-BEA3-A6EF221A6C7B}"/>
+                <a16:creationId xmlns:a16="http://schemas.microsoft.com/office/drawing/2014/main" id="{772103E4-B6D0-4B48-A5DE-70A741B27BFA}"/>
               </a:ext>
             </a:extLst>
           </p:cNvPr>
@@ -1447,7 +1447,7 @@
           <p:cNvPr id="4" name="Date Placeholder 3">
             <a:extLst xmlns:a="http://schemas.openxmlformats.org/drawingml/2006/main">
               <a:ext uri="{FF2B5EF4-FFF2-40B4-BE49-F238E27FC236}">
-                <a16:creationId xmlns:a16="http://schemas.microsoft.com/office/drawing/2014/main" id="{B4E12E00-B9C9-4DE2-AEA5-8163AB7916BC}"/>
+                <a16:creationId xmlns:a16="http://schemas.microsoft.com/office/drawing/2014/main" id="{42B5D9D2-8497-4FA2-A421-A0778FDCFBCC}"/>
               </a:ext>
             </a:extLst>
           </p:cNvPr>
@@ -1475,7 +1475,7 @@
           <p:cNvPr id="5" name="Footer Placeholder 4">
             <a:extLst xmlns:a="http://schemas.openxmlformats.org/drawingml/2006/main">
               <a:ext uri="{FF2B5EF4-FFF2-40B4-BE49-F238E27FC236}">
-                <a16:creationId xmlns:a16="http://schemas.microsoft.com/office/drawing/2014/main" id="{D1FAFC7B-1DB9-4FF7-9304-93EC927C15C5}"/>
+                <a16:creationId xmlns:a16="http://schemas.microsoft.com/office/drawing/2014/main" id="{A102672D-BC2C-49E2-B42E-C0CA37C48CCC}"/>
               </a:ext>
             </a:extLst>
           </p:cNvPr>
@@ -1500,7 +1500,7 @@
           <p:cNvPr id="6" name="Slide Number Placeholder 5">
             <a:extLst xmlns:a="http://schemas.openxmlformats.org/drawingml/2006/main">
               <a:ext uri="{FF2B5EF4-FFF2-40B4-BE49-F238E27FC236}">
-                <a16:creationId xmlns:a16="http://schemas.microsoft.com/office/drawing/2014/main" id="{5604E93A-4485-46F7-8FB9-A5D59D7EBDC8}"/>
+                <a16:creationId xmlns:a16="http://schemas.microsoft.com/office/drawing/2014/main" id="{69319991-E31E-4AF9-BD2F-24D51E495F26}"/>
               </a:ext>
             </a:extLst>
           </p:cNvPr>
@@ -1545,7 +1545,7 @@
           <p:cNvPr id="2" name="Vertical Title 1">
             <a:extLst xmlns:a="http://schemas.openxmlformats.org/drawingml/2006/main">
               <a:ext uri="{FF2B5EF4-FFF2-40B4-BE49-F238E27FC236}">
-                <a16:creationId xmlns:a16="http://schemas.microsoft.com/office/drawing/2014/main" id="{A926B8D7-A9C3-4971-92D3-5DA8328BEEF0}"/>
+                <a16:creationId xmlns:a16="http://schemas.microsoft.com/office/drawing/2014/main" id="{902ACF8A-7615-4AF4-BECF-6D9D149245C8}"/>
               </a:ext>
             </a:extLst>
           </p:cNvPr>
@@ -1578,7 +1578,7 @@
           <p:cNvPr id="3" name="Vertical Text Placeholder 2">
             <a:extLst xmlns:a="http://schemas.openxmlformats.org/drawingml/2006/main">
               <a:ext uri="{FF2B5EF4-FFF2-40B4-BE49-F238E27FC236}">
-                <a16:creationId xmlns:a16="http://schemas.microsoft.com/office/drawing/2014/main" id="{13CB6034-8F8A-47EC-84D4-AC64A1AAD435}"/>
+                <a16:creationId xmlns:a16="http://schemas.microsoft.com/office/drawing/2014/main" id="{61AC6399-CCC1-41A9-9872-9CF1ED7D2C5F}"/>
               </a:ext>
             </a:extLst>
           </p:cNvPr>
@@ -1646,7 +1646,7 @@
           <p:cNvPr id="4" name="Date Placeholder 3">
             <a:extLst xmlns:a="http://schemas.openxmlformats.org/drawingml/2006/main">
               <a:ext uri="{FF2B5EF4-FFF2-40B4-BE49-F238E27FC236}">
-                <a16:creationId xmlns:a16="http://schemas.microsoft.com/office/drawing/2014/main" id="{83A1C896-D012-4812-B1DA-DF64D1871565}"/>
+                <a16:creationId xmlns:a16="http://schemas.microsoft.com/office/drawing/2014/main" id="{1763D6FB-0861-4C62-83BB-7B94B5B7B821}"/>
               </a:ext>
             </a:extLst>
           </p:cNvPr>
@@ -1674,7 +1674,7 @@
           <p:cNvPr id="5" name="Footer Placeholder 4">
             <a:extLst xmlns:a="http://schemas.openxmlformats.org/drawingml/2006/main">
               <a:ext uri="{FF2B5EF4-FFF2-40B4-BE49-F238E27FC236}">
-                <a16:creationId xmlns:a16="http://schemas.microsoft.com/office/drawing/2014/main" id="{713DC872-F964-4DEE-B006-B02919AA16A6}"/>
+                <a16:creationId xmlns:a16="http://schemas.microsoft.com/office/drawing/2014/main" id="{5925CFB0-E1AC-466B-9E76-A28563D66B66}"/>
               </a:ext>
             </a:extLst>
           </p:cNvPr>
@@ -1699,7 +1699,7 @@
           <p:cNvPr id="6" name="Slide Number Placeholder 5">
             <a:extLst xmlns:a="http://schemas.openxmlformats.org/drawingml/2006/main">
               <a:ext uri="{FF2B5EF4-FFF2-40B4-BE49-F238E27FC236}">
-                <a16:creationId xmlns:a16="http://schemas.microsoft.com/office/drawing/2014/main" id="{B92F4605-CE4E-4308-98A4-4894FECAF83C}"/>
+                <a16:creationId xmlns:a16="http://schemas.microsoft.com/office/drawing/2014/main" id="{8E323FCE-1D9A-4D28-B460-899809850826}"/>
               </a:ext>
             </a:extLst>
           </p:cNvPr>
@@ -1744,7 +1744,7 @@
           <p:cNvPr id="2" name="Title 1">
             <a:extLst xmlns:a="http://schemas.openxmlformats.org/drawingml/2006/main">
               <a:ext uri="{FF2B5EF4-FFF2-40B4-BE49-F238E27FC236}">
-                <a16:creationId xmlns:a16="http://schemas.microsoft.com/office/drawing/2014/main" id="{B6DADEC1-98EB-4367-94BE-A4489ED8B7BC}"/>
+                <a16:creationId xmlns:a16="http://schemas.microsoft.com/office/drawing/2014/main" id="{0D29C90B-FB38-45AD-AD61-DF94A90E7F61}"/>
               </a:ext>
             </a:extLst>
           </p:cNvPr>
@@ -1772,7 +1772,7 @@
           <p:cNvPr id="3" name="Content Placeholder 2">
             <a:extLst xmlns:a="http://schemas.openxmlformats.org/drawingml/2006/main">
               <a:ext uri="{FF2B5EF4-FFF2-40B4-BE49-F238E27FC236}">
-                <a16:creationId xmlns:a16="http://schemas.microsoft.com/office/drawing/2014/main" id="{AAA0C9A5-B87D-4E35-8604-E49FE829B3E0}"/>
+                <a16:creationId xmlns:a16="http://schemas.microsoft.com/office/drawing/2014/main" id="{C2685763-083C-4DBC-8402-1522E6D8800E}"/>
               </a:ext>
             </a:extLst>
           </p:cNvPr>
@@ -1835,7 +1835,7 @@
           <p:cNvPr id="4" name="Date Placeholder 3">
             <a:extLst xmlns:a="http://schemas.openxmlformats.org/drawingml/2006/main">
               <a:ext uri="{FF2B5EF4-FFF2-40B4-BE49-F238E27FC236}">
-                <a16:creationId xmlns:a16="http://schemas.microsoft.com/office/drawing/2014/main" id="{D5788EAA-945B-4E34-836C-86E4B8E23DB9}"/>
+                <a16:creationId xmlns:a16="http://schemas.microsoft.com/office/drawing/2014/main" id="{58B839C3-EF81-4338-823F-A361769E9069}"/>
               </a:ext>
             </a:extLst>
           </p:cNvPr>
@@ -1863,7 +1863,7 @@
           <p:cNvPr id="5" name="Footer Placeholder 4">
             <a:extLst xmlns:a="http://schemas.openxmlformats.org/drawingml/2006/main">
               <a:ext uri="{FF2B5EF4-FFF2-40B4-BE49-F238E27FC236}">
-                <a16:creationId xmlns:a16="http://schemas.microsoft.com/office/drawing/2014/main" id="{48553AC7-36F2-4E5E-8D25-52F3053F69F7}"/>
+                <a16:creationId xmlns:a16="http://schemas.microsoft.com/office/drawing/2014/main" id="{68C29264-CFB1-4867-88DA-1F739B3D1948}"/>
               </a:ext>
             </a:extLst>
           </p:cNvPr>
@@ -1888,7 +1888,7 @@
           <p:cNvPr id="6" name="Slide Number Placeholder 5">
             <a:extLst xmlns:a="http://schemas.openxmlformats.org/drawingml/2006/main">
               <a:ext uri="{FF2B5EF4-FFF2-40B4-BE49-F238E27FC236}">
-                <a16:creationId xmlns:a16="http://schemas.microsoft.com/office/drawing/2014/main" id="{6FF2768E-F8AF-4645-9EC2-4DD746F491CA}"/>
+                <a16:creationId xmlns:a16="http://schemas.microsoft.com/office/drawing/2014/main" id="{2E3F2929-967A-4FAA-ACBB-B60E93972E77}"/>
               </a:ext>
             </a:extLst>
           </p:cNvPr>
@@ -1933,7 +1933,7 @@
           <p:cNvPr id="2" name="Title 1">
             <a:extLst xmlns:a="http://schemas.openxmlformats.org/drawingml/2006/main">
               <a:ext uri="{FF2B5EF4-FFF2-40B4-BE49-F238E27FC236}">
-                <a16:creationId xmlns:a16="http://schemas.microsoft.com/office/drawing/2014/main" id="{15BAC2FF-55F5-4554-A0DE-7B2D223E513C}"/>
+                <a16:creationId xmlns:a16="http://schemas.microsoft.com/office/drawing/2014/main" id="{277BAA15-AA7B-4744-95F8-1A334F66EB88}"/>
               </a:ext>
             </a:extLst>
           </p:cNvPr>
@@ -1971,7 +1971,7 @@
           <p:cNvPr id="3" name="Text Placeholder 2">
             <a:extLst xmlns:a="http://schemas.openxmlformats.org/drawingml/2006/main">
               <a:ext uri="{FF2B5EF4-FFF2-40B4-BE49-F238E27FC236}">
-                <a16:creationId xmlns:a16="http://schemas.microsoft.com/office/drawing/2014/main" id="{66701D0F-3E42-42EF-B065-9A51A86C2669}"/>
+                <a16:creationId xmlns:a16="http://schemas.microsoft.com/office/drawing/2014/main" id="{1C788A59-FCE1-43FB-84EA-B38938DDF9BB}"/>
               </a:ext>
             </a:extLst>
           </p:cNvPr>
@@ -2097,7 +2097,7 @@
           <p:cNvPr id="4" name="Date Placeholder 3">
             <a:extLst xmlns:a="http://schemas.openxmlformats.org/drawingml/2006/main">
               <a:ext uri="{FF2B5EF4-FFF2-40B4-BE49-F238E27FC236}">
-                <a16:creationId xmlns:a16="http://schemas.microsoft.com/office/drawing/2014/main" id="{17C81CB4-CEF3-42D5-884D-20BDCEBDACB8}"/>
+                <a16:creationId xmlns:a16="http://schemas.microsoft.com/office/drawing/2014/main" id="{56B29624-D237-450C-8076-DE21B47BF0AE}"/>
               </a:ext>
             </a:extLst>
           </p:cNvPr>
@@ -2125,7 +2125,7 @@
           <p:cNvPr id="5" name="Footer Placeholder 4">
             <a:extLst xmlns:a="http://schemas.openxmlformats.org/drawingml/2006/main">
               <a:ext uri="{FF2B5EF4-FFF2-40B4-BE49-F238E27FC236}">
-                <a16:creationId xmlns:a16="http://schemas.microsoft.com/office/drawing/2014/main" id="{C85652BA-D120-4670-B0FF-3E5FC1042B6A}"/>
+                <a16:creationId xmlns:a16="http://schemas.microsoft.com/office/drawing/2014/main" id="{579D65B8-499E-42B8-A703-848A9CDAE881}"/>
               </a:ext>
             </a:extLst>
           </p:cNvPr>
@@ -2150,7 +2150,7 @@
           <p:cNvPr id="6" name="Slide Number Placeholder 5">
             <a:extLst xmlns:a="http://schemas.openxmlformats.org/drawingml/2006/main">
               <a:ext uri="{FF2B5EF4-FFF2-40B4-BE49-F238E27FC236}">
-                <a16:creationId xmlns:a16="http://schemas.microsoft.com/office/drawing/2014/main" id="{6DF755D4-1A62-4317-8B16-9CA9F8D59D0A}"/>
+                <a16:creationId xmlns:a16="http://schemas.microsoft.com/office/drawing/2014/main" id="{60A9BEF4-6476-4D60-B66F-C9D8E6F42215}"/>
               </a:ext>
             </a:extLst>
           </p:cNvPr>
@@ -2195,7 +2195,7 @@
           <p:cNvPr id="2" name="Title 1">
             <a:extLst xmlns:a="http://schemas.openxmlformats.org/drawingml/2006/main">
               <a:ext uri="{FF2B5EF4-FFF2-40B4-BE49-F238E27FC236}">
-                <a16:creationId xmlns:a16="http://schemas.microsoft.com/office/drawing/2014/main" id="{BAD30A5B-CA71-4AAF-9A04-BC5898B5246D}"/>
+                <a16:creationId xmlns:a16="http://schemas.microsoft.com/office/drawing/2014/main" id="{B68880D9-C0BE-4660-883B-3EB11D8F575C}"/>
               </a:ext>
             </a:extLst>
           </p:cNvPr>
@@ -2223,7 +2223,7 @@
           <p:cNvPr id="3" name="Content Placeholder 2">
             <a:extLst xmlns:a="http://schemas.openxmlformats.org/drawingml/2006/main">
               <a:ext uri="{FF2B5EF4-FFF2-40B4-BE49-F238E27FC236}">
-                <a16:creationId xmlns:a16="http://schemas.microsoft.com/office/drawing/2014/main" id="{7FBEA3E4-8150-4CB2-9A92-993A8514B324}"/>
+                <a16:creationId xmlns:a16="http://schemas.microsoft.com/office/drawing/2014/main" id="{0EFCAB9B-7945-419E-9F07-6CB2163E241E}"/>
               </a:ext>
             </a:extLst>
           </p:cNvPr>
@@ -2328,7 +2328,7 @@
           <p:cNvPr id="4" name="Content Placeholder 3">
             <a:extLst xmlns:a="http://schemas.openxmlformats.org/drawingml/2006/main">
               <a:ext uri="{FF2B5EF4-FFF2-40B4-BE49-F238E27FC236}">
-                <a16:creationId xmlns:a16="http://schemas.microsoft.com/office/drawing/2014/main" id="{187CD55E-3AF7-46AE-8391-744293A3B24C}"/>
+                <a16:creationId xmlns:a16="http://schemas.microsoft.com/office/drawing/2014/main" id="{78579D34-1E57-4C3C-922B-A8A2D72707DF}"/>
               </a:ext>
             </a:extLst>
           </p:cNvPr>
@@ -2433,7 +2433,7 @@
           <p:cNvPr id="5" name="Date Placeholder 4">
             <a:extLst xmlns:a="http://schemas.openxmlformats.org/drawingml/2006/main">
               <a:ext uri="{FF2B5EF4-FFF2-40B4-BE49-F238E27FC236}">
-                <a16:creationId xmlns:a16="http://schemas.microsoft.com/office/drawing/2014/main" id="{FF3A59F4-EB3C-4D12-B219-F711DB009D96}"/>
+                <a16:creationId xmlns:a16="http://schemas.microsoft.com/office/drawing/2014/main" id="{83720593-2AE5-4D60-A492-9D821395D3E1}"/>
               </a:ext>
             </a:extLst>
           </p:cNvPr>
@@ -2461,7 +2461,7 @@
           <p:cNvPr id="6" name="Footer Placeholder 5">
             <a:extLst xmlns:a="http://schemas.openxmlformats.org/drawingml/2006/main">
               <a:ext uri="{FF2B5EF4-FFF2-40B4-BE49-F238E27FC236}">
-                <a16:creationId xmlns:a16="http://schemas.microsoft.com/office/drawing/2014/main" id="{98A8C7E9-909D-40FC-AE5C-934F2E032B9C}"/>
+                <a16:creationId xmlns:a16="http://schemas.microsoft.com/office/drawing/2014/main" id="{6B333AAA-CB27-41AC-B679-2BD1D434D0AB}"/>
               </a:ext>
             </a:extLst>
           </p:cNvPr>
@@ -2486,7 +2486,7 @@
           <p:cNvPr id="7" name="Slide Number Placeholder 6">
             <a:extLst xmlns:a="http://schemas.openxmlformats.org/drawingml/2006/main">
               <a:ext uri="{FF2B5EF4-FFF2-40B4-BE49-F238E27FC236}">
-                <a16:creationId xmlns:a16="http://schemas.microsoft.com/office/drawing/2014/main" id="{E761EEAE-5862-43A9-81E2-8D88924CF700}"/>
+                <a16:creationId xmlns:a16="http://schemas.microsoft.com/office/drawing/2014/main" id="{B75F37F3-1B66-4E6F-979C-B280ADD190C4}"/>
               </a:ext>
             </a:extLst>
           </p:cNvPr>
@@ -2531,7 +2531,7 @@
           <p:cNvPr id="2" name="Title 1">
             <a:extLst xmlns:a="http://schemas.openxmlformats.org/drawingml/2006/main">
               <a:ext uri="{FF2B5EF4-FFF2-40B4-BE49-F238E27FC236}">
-                <a16:creationId xmlns:a16="http://schemas.microsoft.com/office/drawing/2014/main" id="{FDB58968-C0DB-45DC-94D5-F59391E39975}"/>
+                <a16:creationId xmlns:a16="http://schemas.microsoft.com/office/drawing/2014/main" id="{1FBEC438-EDD6-462A-AB00-BF7D8F0E3AFA}"/>
               </a:ext>
             </a:extLst>
           </p:cNvPr>
@@ -2564,7 +2564,7 @@
           <p:cNvPr id="3" name="Text Placeholder 2">
             <a:extLst xmlns:a="http://schemas.openxmlformats.org/drawingml/2006/main">
               <a:ext uri="{FF2B5EF4-FFF2-40B4-BE49-F238E27FC236}">
-                <a16:creationId xmlns:a16="http://schemas.microsoft.com/office/drawing/2014/main" id="{F840D6F6-68D0-4D42-945D-8A13FCB83372}"/>
+                <a16:creationId xmlns:a16="http://schemas.microsoft.com/office/drawing/2014/main" id="{9A16BA59-3534-4F55-8E2D-19874A71023A}"/>
               </a:ext>
             </a:extLst>
           </p:cNvPr>
@@ -2636,7 +2636,7 @@
           <p:cNvPr id="4" name="Content Placeholder 3">
             <a:extLst xmlns:a="http://schemas.openxmlformats.org/drawingml/2006/main">
               <a:ext uri="{FF2B5EF4-FFF2-40B4-BE49-F238E27FC236}">
-                <a16:creationId xmlns:a16="http://schemas.microsoft.com/office/drawing/2014/main" id="{EFA6BEC8-C755-443D-8B6E-B22F643E1ABA}"/>
+                <a16:creationId xmlns:a16="http://schemas.microsoft.com/office/drawing/2014/main" id="{5457BD6C-3FD3-4B1C-9850-769858118A0D}"/>
               </a:ext>
             </a:extLst>
           </p:cNvPr>
@@ -2741,7 +2741,7 @@
           <p:cNvPr id="5" name="Text Placeholder 4">
             <a:extLst xmlns:a="http://schemas.openxmlformats.org/drawingml/2006/main">
               <a:ext uri="{FF2B5EF4-FFF2-40B4-BE49-F238E27FC236}">
-                <a16:creationId xmlns:a16="http://schemas.microsoft.com/office/drawing/2014/main" id="{F076D3F9-763D-4E4F-9360-819ADD65AC1C}"/>
+                <a16:creationId xmlns:a16="http://schemas.microsoft.com/office/drawing/2014/main" id="{C8651B13-1A3E-418B-92EE-996A3FEF9B9F}"/>
               </a:ext>
             </a:extLst>
           </p:cNvPr>
@@ -2813,7 +2813,7 @@
           <p:cNvPr id="6" name="Content Placeholder 5">
             <a:extLst xmlns:a="http://schemas.openxmlformats.org/drawingml/2006/main">
               <a:ext uri="{FF2B5EF4-FFF2-40B4-BE49-F238E27FC236}">
-                <a16:creationId xmlns:a16="http://schemas.microsoft.com/office/drawing/2014/main" id="{746D7AA3-A1C2-474C-8DE6-32EB2CA4637A}"/>
+                <a16:creationId xmlns:a16="http://schemas.microsoft.com/office/drawing/2014/main" id="{4FDA5C4A-2E2C-432F-A780-B6347C38996B}"/>
               </a:ext>
             </a:extLst>
           </p:cNvPr>
@@ -2918,7 +2918,7 @@
           <p:cNvPr id="7" name="Date Placeholder 6">
             <a:extLst xmlns:a="http://schemas.openxmlformats.org/drawingml/2006/main">
               <a:ext uri="{FF2B5EF4-FFF2-40B4-BE49-F238E27FC236}">
-                <a16:creationId xmlns:a16="http://schemas.microsoft.com/office/drawing/2014/main" id="{BE358589-6AB3-4F49-93E5-1EDF9D1CA4D7}"/>
+                <a16:creationId xmlns:a16="http://schemas.microsoft.com/office/drawing/2014/main" id="{BF44FFC4-9E17-49D2-8668-18436EBF3AA6}"/>
               </a:ext>
             </a:extLst>
           </p:cNvPr>
@@ -2946,7 +2946,7 @@
           <p:cNvPr id="8" name="Footer Placeholder 7">
             <a:extLst xmlns:a="http://schemas.openxmlformats.org/drawingml/2006/main">
               <a:ext uri="{FF2B5EF4-FFF2-40B4-BE49-F238E27FC236}">
-                <a16:creationId xmlns:a16="http://schemas.microsoft.com/office/drawing/2014/main" id="{8B5400DB-46D0-4444-B04D-9229032B3ECE}"/>
+                <a16:creationId xmlns:a16="http://schemas.microsoft.com/office/drawing/2014/main" id="{6F099CA2-DD3A-4AB2-B421-B3C83EB1DA51}"/>
               </a:ext>
             </a:extLst>
           </p:cNvPr>
@@ -2971,7 +2971,7 @@
           <p:cNvPr id="9" name="Slide Number Placeholder 8">
             <a:extLst xmlns:a="http://schemas.openxmlformats.org/drawingml/2006/main">
               <a:ext uri="{FF2B5EF4-FFF2-40B4-BE49-F238E27FC236}">
-                <a16:creationId xmlns:a16="http://schemas.microsoft.com/office/drawing/2014/main" id="{D5A76BD3-8803-4962-A202-168FCF51B605}"/>
+                <a16:creationId xmlns:a16="http://schemas.microsoft.com/office/drawing/2014/main" id="{239E4F7E-F308-4B67-A2D3-AA95E6D55B1D}"/>
               </a:ext>
             </a:extLst>
           </p:cNvPr>
@@ -3016,7 +3016,7 @@
           <p:cNvPr id="2" name="Title 1">
             <a:extLst xmlns:a="http://schemas.openxmlformats.org/drawingml/2006/main">
               <a:ext uri="{FF2B5EF4-FFF2-40B4-BE49-F238E27FC236}">
-                <a16:creationId xmlns:a16="http://schemas.microsoft.com/office/drawing/2014/main" id="{517E8F5B-FD31-45FA-8A85-50C68C3396CD}"/>
+                <a16:creationId xmlns:a16="http://schemas.microsoft.com/office/drawing/2014/main" id="{BF7FDB69-8471-46EB-AA1B-D5CAD2C2BB3E}"/>
               </a:ext>
             </a:extLst>
           </p:cNvPr>
@@ -3044,7 +3044,7 @@
           <p:cNvPr id="3" name="Date Placeholder 2">
             <a:extLst xmlns:a="http://schemas.openxmlformats.org/drawingml/2006/main">
               <a:ext uri="{FF2B5EF4-FFF2-40B4-BE49-F238E27FC236}">
-                <a16:creationId xmlns:a16="http://schemas.microsoft.com/office/drawing/2014/main" id="{FD9746B9-CCDB-4932-B439-CCEF17DD8C59}"/>
+                <a16:creationId xmlns:a16="http://schemas.microsoft.com/office/drawing/2014/main" id="{CE0BA8F9-AB49-41FE-93B8-E7FD84A1067D}"/>
               </a:ext>
             </a:extLst>
           </p:cNvPr>
@@ -3072,7 +3072,7 @@
           <p:cNvPr id="4" name="Footer Placeholder 3">
             <a:extLst xmlns:a="http://schemas.openxmlformats.org/drawingml/2006/main">
               <a:ext uri="{FF2B5EF4-FFF2-40B4-BE49-F238E27FC236}">
-                <a16:creationId xmlns:a16="http://schemas.microsoft.com/office/drawing/2014/main" id="{A13781D6-4AC8-4EA8-B748-EDC3CE72E9D0}"/>
+                <a16:creationId xmlns:a16="http://schemas.microsoft.com/office/drawing/2014/main" id="{E0800D72-61D7-40C8-A57E-2ACFFCBC4B8B}"/>
               </a:ext>
             </a:extLst>
           </p:cNvPr>
@@ -3097,7 +3097,7 @@
           <p:cNvPr id="5" name="Slide Number Placeholder 4">
             <a:extLst xmlns:a="http://schemas.openxmlformats.org/drawingml/2006/main">
               <a:ext uri="{FF2B5EF4-FFF2-40B4-BE49-F238E27FC236}">
-                <a16:creationId xmlns:a16="http://schemas.microsoft.com/office/drawing/2014/main" id="{56959B05-F97B-466A-8B7C-2904283F3038}"/>
+                <a16:creationId xmlns:a16="http://schemas.microsoft.com/office/drawing/2014/main" id="{B9F950AA-2009-45A7-A7CA-531315CECE89}"/>
               </a:ext>
             </a:extLst>
           </p:cNvPr>
@@ -3142,7 +3142,7 @@
           <p:cNvPr id="2" name="Date Placeholder 1">
             <a:extLst xmlns:a="http://schemas.openxmlformats.org/drawingml/2006/main">
               <a:ext uri="{FF2B5EF4-FFF2-40B4-BE49-F238E27FC236}">
-                <a16:creationId xmlns:a16="http://schemas.microsoft.com/office/drawing/2014/main" id="{94292C22-80A9-4685-8B03-B8E76DBF7CF8}"/>
+                <a16:creationId xmlns:a16="http://schemas.microsoft.com/office/drawing/2014/main" id="{4A564ABF-CC71-4252-B60D-B861E61F927C}"/>
               </a:ext>
             </a:extLst>
           </p:cNvPr>
@@ -3170,7 +3170,7 @@
           <p:cNvPr id="3" name="Footer Placeholder 2">
             <a:extLst xmlns:a="http://schemas.openxmlformats.org/drawingml/2006/main">
               <a:ext uri="{FF2B5EF4-FFF2-40B4-BE49-F238E27FC236}">
-                <a16:creationId xmlns:a16="http://schemas.microsoft.com/office/drawing/2014/main" id="{A4A9F055-0C9D-4765-9510-AE1CBF2EA4C6}"/>
+                <a16:creationId xmlns:a16="http://schemas.microsoft.com/office/drawing/2014/main" id="{F817D34A-99E0-4BFD-98C8-EF7C0E44A9B9}"/>
               </a:ext>
             </a:extLst>
           </p:cNvPr>
@@ -3195,7 +3195,7 @@
           <p:cNvPr id="4" name="Slide Number Placeholder 3">
             <a:extLst xmlns:a="http://schemas.openxmlformats.org/drawingml/2006/main">
               <a:ext uri="{FF2B5EF4-FFF2-40B4-BE49-F238E27FC236}">
-                <a16:creationId xmlns:a16="http://schemas.microsoft.com/office/drawing/2014/main" id="{9703E606-BD15-482E-89CE-CA3EE3E0CDFF}"/>
+                <a16:creationId xmlns:a16="http://schemas.microsoft.com/office/drawing/2014/main" id="{2640647A-13AB-4F5B-BA74-20B9CB25319B}"/>
               </a:ext>
             </a:extLst>
           </p:cNvPr>
@@ -3240,7 +3240,7 @@
           <p:cNvPr id="2" name="Title 1">
             <a:extLst xmlns:a="http://schemas.openxmlformats.org/drawingml/2006/main">
               <a:ext uri="{FF2B5EF4-FFF2-40B4-BE49-F238E27FC236}">
-                <a16:creationId xmlns:a16="http://schemas.microsoft.com/office/drawing/2014/main" id="{4DDC81D8-C225-4C14-AE25-D044A7D25460}"/>
+                <a16:creationId xmlns:a16="http://schemas.microsoft.com/office/drawing/2014/main" id="{DF2E63A3-C425-405F-B629-6697655FE9BF}"/>
               </a:ext>
             </a:extLst>
           </p:cNvPr>
@@ -3278,7 +3278,7 @@
           <p:cNvPr id="3" name="Content Placeholder 2">
             <a:extLst xmlns:a="http://schemas.openxmlformats.org/drawingml/2006/main">
               <a:ext uri="{FF2B5EF4-FFF2-40B4-BE49-F238E27FC236}">
-                <a16:creationId xmlns:a16="http://schemas.microsoft.com/office/drawing/2014/main" id="{5F2101C3-9FB6-435E-9F12-8AC4A2B03226}"/>
+                <a16:creationId xmlns:a16="http://schemas.microsoft.com/office/drawing/2014/main" id="{9F039862-00D6-4E72-BFC6-3B41BE467AB5}"/>
               </a:ext>
             </a:extLst>
           </p:cNvPr>
@@ -3383,7 +3383,7 @@
           <p:cNvPr id="4" name="Text Placeholder 3">
             <a:extLst xmlns:a="http://schemas.openxmlformats.org/drawingml/2006/main">
               <a:ext uri="{FF2B5EF4-FFF2-40B4-BE49-F238E27FC236}">
-                <a16:creationId xmlns:a16="http://schemas.microsoft.com/office/drawing/2014/main" id="{8D5C2AD5-629F-4DC8-B2DA-EEE7B7800988}"/>
+                <a16:creationId xmlns:a16="http://schemas.microsoft.com/office/drawing/2014/main" id="{716151F8-0404-41FD-A235-1C34A8B5BD7A}"/>
               </a:ext>
             </a:extLst>
           </p:cNvPr>
@@ -3455,7 +3455,7 @@
           <p:cNvPr id="5" name="Date Placeholder 4">
             <a:extLst xmlns:a="http://schemas.openxmlformats.org/drawingml/2006/main">
               <a:ext uri="{FF2B5EF4-FFF2-40B4-BE49-F238E27FC236}">
-                <a16:creationId xmlns:a16="http://schemas.microsoft.com/office/drawing/2014/main" id="{181244B6-DA5B-46E9-8C96-112FE83184F5}"/>
+                <a16:creationId xmlns:a16="http://schemas.microsoft.com/office/drawing/2014/main" id="{9B765446-33D2-4307-B475-5A9BA5052DA3}"/>
               </a:ext>
             </a:extLst>
           </p:cNvPr>
@@ -3483,7 +3483,7 @@
           <p:cNvPr id="6" name="Footer Placeholder 5">
             <a:extLst xmlns:a="http://schemas.openxmlformats.org/drawingml/2006/main">
               <a:ext uri="{FF2B5EF4-FFF2-40B4-BE49-F238E27FC236}">
-                <a16:creationId xmlns:a16="http://schemas.microsoft.com/office/drawing/2014/main" id="{5B42DDFC-FAF4-43D9-A16A-379ED772E81F}"/>
+                <a16:creationId xmlns:a16="http://schemas.microsoft.com/office/drawing/2014/main" id="{085AFDA9-3248-43A3-BF3E-6A05230F8D62}"/>
               </a:ext>
             </a:extLst>
           </p:cNvPr>
@@ -3508,7 +3508,7 @@
           <p:cNvPr id="7" name="Slide Number Placeholder 6">
             <a:extLst xmlns:a="http://schemas.openxmlformats.org/drawingml/2006/main">
               <a:ext uri="{FF2B5EF4-FFF2-40B4-BE49-F238E27FC236}">
-                <a16:creationId xmlns:a16="http://schemas.microsoft.com/office/drawing/2014/main" id="{C8BB88D1-012A-422C-A0DD-E6EEBBFE2C9A}"/>
+                <a16:creationId xmlns:a16="http://schemas.microsoft.com/office/drawing/2014/main" id="{163200A1-0BA3-4D2B-855B-D64F18B48ACB}"/>
               </a:ext>
             </a:extLst>
           </p:cNvPr>
@@ -3553,7 +3553,7 @@
           <p:cNvPr id="2" name="Title 1">
             <a:extLst xmlns:a="http://schemas.openxmlformats.org/drawingml/2006/main">
               <a:ext uri="{FF2B5EF4-FFF2-40B4-BE49-F238E27FC236}">
-                <a16:creationId xmlns:a16="http://schemas.microsoft.com/office/drawing/2014/main" id="{E3CF0677-0BBA-40D5-B1DD-B80B8B707C90}"/>
+                <a16:creationId xmlns:a16="http://schemas.microsoft.com/office/drawing/2014/main" id="{3C0E1B00-9943-426E-8957-E88DA3B37F9C}"/>
               </a:ext>
             </a:extLst>
           </p:cNvPr>
@@ -3591,7 +3591,7 @@
           <p:cNvPr id="3" name="Picture Placeholder 2">
             <a:extLst xmlns:a="http://schemas.openxmlformats.org/drawingml/2006/main">
               <a:ext uri="{FF2B5EF4-FFF2-40B4-BE49-F238E27FC236}">
-                <a16:creationId xmlns:a16="http://schemas.microsoft.com/office/drawing/2014/main" id="{BA232386-994F-4E8E-A86C-B12F10A0DD11}"/>
+                <a16:creationId xmlns:a16="http://schemas.microsoft.com/office/drawing/2014/main" id="{62082D28-9F15-4559-89FB-C431F63970B4}"/>
               </a:ext>
             </a:extLst>
           </p:cNvPr>
@@ -3658,7 +3658,7 @@
           <p:cNvPr id="4" name="Text Placeholder 3">
             <a:extLst xmlns:a="http://schemas.openxmlformats.org/drawingml/2006/main">
               <a:ext uri="{FF2B5EF4-FFF2-40B4-BE49-F238E27FC236}">
-                <a16:creationId xmlns:a16="http://schemas.microsoft.com/office/drawing/2014/main" id="{2CD44091-9C50-4D07-AFAF-1AF67773BBBA}"/>
+                <a16:creationId xmlns:a16="http://schemas.microsoft.com/office/drawing/2014/main" id="{5FDEEC1B-54ED-431D-96CA-4D79CD0B89AA}"/>
               </a:ext>
             </a:extLst>
           </p:cNvPr>
@@ -3730,7 +3730,7 @@
           <p:cNvPr id="5" name="Date Placeholder 4">
             <a:extLst xmlns:a="http://schemas.openxmlformats.org/drawingml/2006/main">
               <a:ext uri="{FF2B5EF4-FFF2-40B4-BE49-F238E27FC236}">
-                <a16:creationId xmlns:a16="http://schemas.microsoft.com/office/drawing/2014/main" id="{65E0256B-1EA4-4E8F-A226-528B5ED27FA7}"/>
+                <a16:creationId xmlns:a16="http://schemas.microsoft.com/office/drawing/2014/main" id="{F07EEB1F-869F-47F0-9189-D8EAC947CCE8}"/>
               </a:ext>
             </a:extLst>
           </p:cNvPr>
@@ -3758,7 +3758,7 @@
           <p:cNvPr id="6" name="Footer Placeholder 5">
             <a:extLst xmlns:a="http://schemas.openxmlformats.org/drawingml/2006/main">
               <a:ext uri="{FF2B5EF4-FFF2-40B4-BE49-F238E27FC236}">
-                <a16:creationId xmlns:a16="http://schemas.microsoft.com/office/drawing/2014/main" id="{17126B37-7ADF-4942-A098-F710FC8A3847}"/>
+                <a16:creationId xmlns:a16="http://schemas.microsoft.com/office/drawing/2014/main" id="{814023A0-1EF0-498B-9614-59B284265C44}"/>
               </a:ext>
             </a:extLst>
           </p:cNvPr>
@@ -3783,7 +3783,7 @@
           <p:cNvPr id="7" name="Slide Number Placeholder 6">
             <a:extLst xmlns:a="http://schemas.openxmlformats.org/drawingml/2006/main">
               <a:ext uri="{FF2B5EF4-FFF2-40B4-BE49-F238E27FC236}">
-                <a16:creationId xmlns:a16="http://schemas.microsoft.com/office/drawing/2014/main" id="{0B7CDD3A-85EE-486E-9993-4E8817E442EF}"/>
+                <a16:creationId xmlns:a16="http://schemas.microsoft.com/office/drawing/2014/main" id="{CD312905-10C0-4E95-AF1F-734B8D1158EA}"/>
               </a:ext>
             </a:extLst>
           </p:cNvPr>
@@ -3833,7 +3833,7 @@
           <p:cNvPr id="2" name="Title Placeholder 1">
             <a:extLst xmlns:a="http://schemas.openxmlformats.org/drawingml/2006/main">
               <a:ext uri="{FF2B5EF4-FFF2-40B4-BE49-F238E27FC236}">
-                <a16:creationId xmlns:a16="http://schemas.microsoft.com/office/drawing/2014/main" id="{370CF799-9906-4F32-9C55-728C5B005999}"/>
+                <a16:creationId xmlns:a16="http://schemas.microsoft.com/office/drawing/2014/main" id="{24B130FA-3C09-4C26-8345-ECD74F87BB0F}"/>
               </a:ext>
             </a:extLst>
           </p:cNvPr>
@@ -3871,7 +3871,7 @@
           <p:cNvPr id="3" name="Text Placeholder 2">
             <a:extLst xmlns:a="http://schemas.openxmlformats.org/drawingml/2006/main">
               <a:ext uri="{FF2B5EF4-FFF2-40B4-BE49-F238E27FC236}">
-                <a16:creationId xmlns:a16="http://schemas.microsoft.com/office/drawing/2014/main" id="{84C4F4FD-8F4F-435F-9720-28829F4BE750}"/>
+                <a16:creationId xmlns:a16="http://schemas.microsoft.com/office/drawing/2014/main" id="{9090107D-819C-4EDA-9CF2-5A690E2B2C4A}"/>
               </a:ext>
             </a:extLst>
           </p:cNvPr>
@@ -3944,7 +3944,7 @@
           <p:cNvPr id="4" name="Date Placeholder 3">
             <a:extLst xmlns:a="http://schemas.openxmlformats.org/drawingml/2006/main">
               <a:ext uri="{FF2B5EF4-FFF2-40B4-BE49-F238E27FC236}">
-                <a16:creationId xmlns:a16="http://schemas.microsoft.com/office/drawing/2014/main" id="{722A12EC-FD77-4345-A501-E689FCBAA226}"/>
+                <a16:creationId xmlns:a16="http://schemas.microsoft.com/office/drawing/2014/main" id="{935283FC-1C43-4FE5-9E2B-FAF846F149F9}"/>
               </a:ext>
             </a:extLst>
           </p:cNvPr>
@@ -3991,7 +3991,7 @@
           <p:cNvPr id="5" name="Footer Placeholder 4">
             <a:extLst xmlns:a="http://schemas.openxmlformats.org/drawingml/2006/main">
               <a:ext uri="{FF2B5EF4-FFF2-40B4-BE49-F238E27FC236}">
-                <a16:creationId xmlns:a16="http://schemas.microsoft.com/office/drawing/2014/main" id="{34395A66-B0F5-4AA7-8E5E-9E3075BC1416}"/>
+                <a16:creationId xmlns:a16="http://schemas.microsoft.com/office/drawing/2014/main" id="{75E5B398-5072-4F4B-89F3-F9600C6B0470}"/>
               </a:ext>
             </a:extLst>
           </p:cNvPr>
@@ -4035,7 +4035,7 @@
           <p:cNvPr id="6" name="Slide Number Placeholder 5">
             <a:extLst xmlns:a="http://schemas.openxmlformats.org/drawingml/2006/main">
               <a:ext uri="{FF2B5EF4-FFF2-40B4-BE49-F238E27FC236}">
-                <a16:creationId xmlns:a16="http://schemas.microsoft.com/office/drawing/2014/main" id="{E16DF0A3-DC0A-46EF-BB37-41BC83B3824B}"/>
+                <a16:creationId xmlns:a16="http://schemas.microsoft.com/office/drawing/2014/main" id="{043240A4-C735-49C9-B3AB-FFA75C269E93}"/>
               </a:ext>
             </a:extLst>
           </p:cNvPr>
@@ -4081,17 +4081,17 @@
   </p:cSld>
   <p:clrMap bg1="lt1" tx1="dk1" bg2="lt2" tx2="dk2" accent1="accent1" accent2="accent2" accent3="accent3" accent4="accent4" accent5="accent5" accent6="accent6" hlink="hlink" folHlink="folHlink"/>
   <p:sldLayoutIdLst>
-    <p:sldLayoutId xmlns:r="http://schemas.openxmlformats.org/officeDocument/2006/relationships" id="2147483649" r:id="Rd1c23a7370c245eb"/>
-    <p:sldLayoutId xmlns:r="http://schemas.openxmlformats.org/officeDocument/2006/relationships" id="2147483650" r:id="R332ce2bb48fd4497"/>
-    <p:sldLayoutId xmlns:r="http://schemas.openxmlformats.org/officeDocument/2006/relationships" id="2147483651" r:id="Rd3f2c8c714b149df"/>
-    <p:sldLayoutId xmlns:r="http://schemas.openxmlformats.org/officeDocument/2006/relationships" id="2147483652" r:id="R069b698ffee64c3c"/>
-    <p:sldLayoutId xmlns:r="http://schemas.openxmlformats.org/officeDocument/2006/relationships" id="2147483653" r:id="R15ef3b94f2674a6f"/>
-    <p:sldLayoutId xmlns:r="http://schemas.openxmlformats.org/officeDocument/2006/relationships" id="2147483654" r:id="R85318bbd24e14a47"/>
-    <p:sldLayoutId xmlns:r="http://schemas.openxmlformats.org/officeDocument/2006/relationships" id="2147483655" r:id="R1665043e0c2a4968"/>
-    <p:sldLayoutId xmlns:r="http://schemas.openxmlformats.org/officeDocument/2006/relationships" id="2147483656" r:id="Rd3625de12f28471a"/>
-    <p:sldLayoutId xmlns:r="http://schemas.openxmlformats.org/officeDocument/2006/relationships" id="2147483657" r:id="Rcfeb96199d7f4107"/>
-    <p:sldLayoutId xmlns:r="http://schemas.openxmlformats.org/officeDocument/2006/relationships" id="2147483658" r:id="R2af24142047c4559"/>
-    <p:sldLayoutId xmlns:r="http://schemas.openxmlformats.org/officeDocument/2006/relationships" id="2147483659" r:id="R425098087d39493a"/>
+    <p:sldLayoutId xmlns:r="http://schemas.openxmlformats.org/officeDocument/2006/relationships" id="2147483649" r:id="Rfedaf63926f942d7"/>
+    <p:sldLayoutId xmlns:r="http://schemas.openxmlformats.org/officeDocument/2006/relationships" id="2147483650" r:id="Rfab9a6c23a364449"/>
+    <p:sldLayoutId xmlns:r="http://schemas.openxmlformats.org/officeDocument/2006/relationships" id="2147483651" r:id="R8d44c09272414d72"/>
+    <p:sldLayoutId xmlns:r="http://schemas.openxmlformats.org/officeDocument/2006/relationships" id="2147483652" r:id="Re5c322859e234453"/>
+    <p:sldLayoutId xmlns:r="http://schemas.openxmlformats.org/officeDocument/2006/relationships" id="2147483653" r:id="R75b2f90e946e4939"/>
+    <p:sldLayoutId xmlns:r="http://schemas.openxmlformats.org/officeDocument/2006/relationships" id="2147483654" r:id="R3b522cdd7f4644e5"/>
+    <p:sldLayoutId xmlns:r="http://schemas.openxmlformats.org/officeDocument/2006/relationships" id="2147483655" r:id="Rf5dc34ad02e84259"/>
+    <p:sldLayoutId xmlns:r="http://schemas.openxmlformats.org/officeDocument/2006/relationships" id="2147483656" r:id="Rcc6454e92bd44ec3"/>
+    <p:sldLayoutId xmlns:r="http://schemas.openxmlformats.org/officeDocument/2006/relationships" id="2147483657" r:id="Re77a34e46fbd4df3"/>
+    <p:sldLayoutId xmlns:r="http://schemas.openxmlformats.org/officeDocument/2006/relationships" id="2147483658" r:id="R4b1178ee77e94dff"/>
+    <p:sldLayoutId xmlns:r="http://schemas.openxmlformats.org/officeDocument/2006/relationships" id="2147483659" r:id="R1fb4c987711a47b2"/>
   </p:sldLayoutIdLst>
   <p:txStyles>
     <p:titleStyle>
@@ -4644,7 +4644,7 @@
           <p:cNvPr id="2" name="TextBox 1">
             <a:extLst xmlns:a="http://schemas.openxmlformats.org/drawingml/2006/main">
               <a:ext uri="{FF2B5EF4-FFF2-40B4-BE49-F238E27FC236}">
-                <a16:creationId xmlns:a16="http://schemas.microsoft.com/office/drawing/2014/main" id="{BFA7DC30-8DAA-4A52-B157-8F89CE545E44}"/>
+                <a16:creationId xmlns:a16="http://schemas.microsoft.com/office/drawing/2014/main" id="{3C43C98B-1AE5-446A-85DF-A1D3F8DABCC1}"/>
               </a:ext>
             </a:extLst>
           </p:cNvPr>
@@ -4694,7 +4694,7 @@
           <p:cNvPr id="3" name="TextBox 2">
             <a:extLst xmlns:a="http://schemas.openxmlformats.org/drawingml/2006/main">
               <a:ext uri="{FF2B5EF4-FFF2-40B4-BE49-F238E27FC236}">
-                <a16:creationId xmlns:a16="http://schemas.microsoft.com/office/drawing/2014/main" id="{BA6A9EA4-4664-425D-8AF8-6B9CF0E08285}"/>
+                <a16:creationId xmlns:a16="http://schemas.microsoft.com/office/drawing/2014/main" id="{06ADE4B7-9BD8-41E3-8003-5F2363A655B6}"/>
               </a:ext>
             </a:extLst>
           </p:cNvPr>
@@ -4744,7 +4744,7 @@
           <p:cNvPr id="4" name="TextBox 3">
             <a:extLst xmlns:a="http://schemas.openxmlformats.org/drawingml/2006/main">
               <a:ext uri="{FF2B5EF4-FFF2-40B4-BE49-F238E27FC236}">
-                <a16:creationId xmlns:a16="http://schemas.microsoft.com/office/drawing/2014/main" id="{62E00D65-A3C3-4C01-9871-5C1087D133CD}"/>
+                <a16:creationId xmlns:a16="http://schemas.microsoft.com/office/drawing/2014/main" id="{AE384C04-265F-464D-9285-13908D4369C0}"/>
               </a:ext>
             </a:extLst>
           </p:cNvPr>
@@ -4794,7 +4794,7 @@
           <p:cNvPr id="5" name="TextBox 4">
             <a:extLst xmlns:a="http://schemas.openxmlformats.org/drawingml/2006/main">
               <a:ext uri="{FF2B5EF4-FFF2-40B4-BE49-F238E27FC236}">
-                <a16:creationId xmlns:a16="http://schemas.microsoft.com/office/drawing/2014/main" id="{A1C5A0E3-DC60-4A16-870F-591B9F7A769E}"/>
+                <a16:creationId xmlns:a16="http://schemas.microsoft.com/office/drawing/2014/main" id="{CE3D5B31-169B-4DC7-A733-1A1EE32A4292}"/>
               </a:ext>
             </a:extLst>
           </p:cNvPr>
@@ -4863,7 +4863,7 @@
           <p:cNvPr id="6" name="TextBox 5">
             <a:extLst xmlns:a="http://schemas.openxmlformats.org/drawingml/2006/main">
               <a:ext uri="{FF2B5EF4-FFF2-40B4-BE49-F238E27FC236}">
-                <a16:creationId xmlns:a16="http://schemas.microsoft.com/office/drawing/2014/main" id="{A4657061-62F5-4463-89F9-ED91160D82BC}"/>
+                <a16:creationId xmlns:a16="http://schemas.microsoft.com/office/drawing/2014/main" id="{21547B40-EE60-41C0-BCAC-E335595ADDA9}"/>
               </a:ext>
             </a:extLst>
           </p:cNvPr>
@@ -4911,7 +4911,7 @@
     </p:spTree>
     <p:extLst>
       <p:ext uri="{BB962C8B-B14F-4D97-AF65-F5344CB8AC3E}">
-        <p14:creationId xmlns:p14="http://schemas.microsoft.com/office/powerpoint/2010/main" val="981838734"/>
+        <p14:creationId xmlns:p14="http://schemas.microsoft.com/office/powerpoint/2010/main" val="1236998541"/>
       </p:ext>
     </p:extLst>
   </p:cSld>
@@ -4942,7 +4942,7 @@
           <p:cNvPr id="2" name="TextBox 1">
             <a:extLst xmlns:a="http://schemas.openxmlformats.org/drawingml/2006/main">
               <a:ext uri="{FF2B5EF4-FFF2-40B4-BE49-F238E27FC236}">
-                <a16:creationId xmlns:a16="http://schemas.microsoft.com/office/drawing/2014/main" id="{58144D11-E17F-4EBF-8EFC-2106E3BA1D2A}"/>
+                <a16:creationId xmlns:a16="http://schemas.microsoft.com/office/drawing/2014/main" id="{F4434369-2BE4-4C0F-8D4A-3D196E01D520}"/>
               </a:ext>
             </a:extLst>
           </p:cNvPr>
@@ -4992,7 +4992,7 @@
           <p:cNvPr id="3" name="TextBox 2">
             <a:extLst xmlns:a="http://schemas.openxmlformats.org/drawingml/2006/main">
               <a:ext uri="{FF2B5EF4-FFF2-40B4-BE49-F238E27FC236}">
-                <a16:creationId xmlns:a16="http://schemas.microsoft.com/office/drawing/2014/main" id="{0304354E-76E2-43AC-A96E-0C7D28840B6B}"/>
+                <a16:creationId xmlns:a16="http://schemas.microsoft.com/office/drawing/2014/main" id="{90CE741C-5302-4B90-97D3-A9C7415D00DE}"/>
               </a:ext>
             </a:extLst>
           </p:cNvPr>
@@ -5042,7 +5042,7 @@
           <p:cNvPr id="4" name="TextBox 3">
             <a:extLst xmlns:a="http://schemas.openxmlformats.org/drawingml/2006/main">
               <a:ext uri="{FF2B5EF4-FFF2-40B4-BE49-F238E27FC236}">
-                <a16:creationId xmlns:a16="http://schemas.microsoft.com/office/drawing/2014/main" id="{09F7D7C9-4BC7-495E-AB51-FF85EBD81360}"/>
+                <a16:creationId xmlns:a16="http://schemas.microsoft.com/office/drawing/2014/main" id="{457CF57E-0195-4B66-93BA-D05E9C58C574}"/>
               </a:ext>
             </a:extLst>
           </p:cNvPr>
@@ -5092,7 +5092,7 @@
           <p:cNvPr id="5" name="Rounded Rectangle 4">
             <a:extLst xmlns:a="http://schemas.openxmlformats.org/drawingml/2006/main">
               <a:ext uri="{FF2B5EF4-FFF2-40B4-BE49-F238E27FC236}">
-                <a16:creationId xmlns:a16="http://schemas.microsoft.com/office/drawing/2014/main" id="{D2A4F31C-4F1E-4FC1-A3D6-082F52A6A11E}"/>
+                <a16:creationId xmlns:a16="http://schemas.microsoft.com/office/drawing/2014/main" id="{C29398C3-5FBA-4F1C-BFC8-D701F5088103}"/>
               </a:ext>
             </a:extLst>
           </p:cNvPr>
@@ -5147,7 +5147,7 @@
           <p:cNvPr id="6" name="TextBox 5">
             <a:extLst xmlns:a="http://schemas.openxmlformats.org/drawingml/2006/main">
               <a:ext uri="{FF2B5EF4-FFF2-40B4-BE49-F238E27FC236}">
-                <a16:creationId xmlns:a16="http://schemas.microsoft.com/office/drawing/2014/main" id="{E0791CC7-026D-4862-9123-4BF5B050389E}"/>
+                <a16:creationId xmlns:a16="http://schemas.microsoft.com/office/drawing/2014/main" id="{1EF45391-742D-42A5-A4E9-92BC384CE6D2}"/>
               </a:ext>
             </a:extLst>
           </p:cNvPr>
@@ -5216,7 +5216,7 @@
           <p:cNvPr id="7" name="Connector 6">
             <a:extLst xmlns:a="http://schemas.openxmlformats.org/drawingml/2006/main">
               <a:ext uri="{FF2B5EF4-FFF2-40B4-BE49-F238E27FC236}">
-                <a16:creationId xmlns:a16="http://schemas.microsoft.com/office/drawing/2014/main" id="{DB2DFED1-0817-4B00-B768-37C7F34CA114}"/>
+                <a16:creationId xmlns:a16="http://schemas.microsoft.com/office/drawing/2014/main" id="{19893801-D703-4569-A734-42A9873D0877}"/>
               </a:ext>
             </a:extLst>
           </p:cNvPr>
@@ -5259,7 +5259,7 @@
           <p:cNvPr id="8" name="Rounded Rectangle 7">
             <a:extLst xmlns:a="http://schemas.openxmlformats.org/drawingml/2006/main">
               <a:ext uri="{FF2B5EF4-FFF2-40B4-BE49-F238E27FC236}">
-                <a16:creationId xmlns:a16="http://schemas.microsoft.com/office/drawing/2014/main" id="{C43E6929-76A0-431F-A047-07304A4C03B4}"/>
+                <a16:creationId xmlns:a16="http://schemas.microsoft.com/office/drawing/2014/main" id="{B2F6EBF7-0BA6-482F-8472-6A7D58A07401}"/>
               </a:ext>
             </a:extLst>
           </p:cNvPr>
@@ -5314,7 +5314,7 @@
           <p:cNvPr id="9" name="TextBox 8">
             <a:extLst xmlns:a="http://schemas.openxmlformats.org/drawingml/2006/main">
               <a:ext uri="{FF2B5EF4-FFF2-40B4-BE49-F238E27FC236}">
-                <a16:creationId xmlns:a16="http://schemas.microsoft.com/office/drawing/2014/main" id="{C0B911BB-ED73-41AF-BD1B-5FDAF1A55022}"/>
+                <a16:creationId xmlns:a16="http://schemas.microsoft.com/office/drawing/2014/main" id="{2C0C164B-B2AB-4875-9CE2-7D81AC155EE6}"/>
               </a:ext>
             </a:extLst>
           </p:cNvPr>
@@ -5383,7 +5383,7 @@
           <p:cNvPr id="10" name="Connector 9">
             <a:extLst xmlns:a="http://schemas.openxmlformats.org/drawingml/2006/main">
               <a:ext uri="{FF2B5EF4-FFF2-40B4-BE49-F238E27FC236}">
-                <a16:creationId xmlns:a16="http://schemas.microsoft.com/office/drawing/2014/main" id="{62D746B1-BE8A-48A5-9FB0-CCA1D4E6EBAE}"/>
+                <a16:creationId xmlns:a16="http://schemas.microsoft.com/office/drawing/2014/main" id="{60341E9E-8467-462E-904B-336D6EDE76B9}"/>
               </a:ext>
             </a:extLst>
           </p:cNvPr>
@@ -5426,7 +5426,7 @@
           <p:cNvPr id="11" name="Rounded Rectangle 10">
             <a:extLst xmlns:a="http://schemas.openxmlformats.org/drawingml/2006/main">
               <a:ext uri="{FF2B5EF4-FFF2-40B4-BE49-F238E27FC236}">
-                <a16:creationId xmlns:a16="http://schemas.microsoft.com/office/drawing/2014/main" id="{05B9FEA8-C618-448E-B758-183305813C2F}"/>
+                <a16:creationId xmlns:a16="http://schemas.microsoft.com/office/drawing/2014/main" id="{FD5CB14E-E0FA-4A88-96D9-A884DAA283B9}"/>
               </a:ext>
             </a:extLst>
           </p:cNvPr>
@@ -5481,7 +5481,7 @@
           <p:cNvPr id="12" name="TextBox 11">
             <a:extLst xmlns:a="http://schemas.openxmlformats.org/drawingml/2006/main">
               <a:ext uri="{FF2B5EF4-FFF2-40B4-BE49-F238E27FC236}">
-                <a16:creationId xmlns:a16="http://schemas.microsoft.com/office/drawing/2014/main" id="{0AD06B87-CA61-4BD8-ABC3-65933557D3F2}"/>
+                <a16:creationId xmlns:a16="http://schemas.microsoft.com/office/drawing/2014/main" id="{F9D7DF83-2A17-46C7-A1D0-035E893A4DFC}"/>
               </a:ext>
             </a:extLst>
           </p:cNvPr>
@@ -5550,7 +5550,7 @@
           <p:cNvPr id="13" name="Connector 12">
             <a:extLst xmlns:a="http://schemas.openxmlformats.org/drawingml/2006/main">
               <a:ext uri="{FF2B5EF4-FFF2-40B4-BE49-F238E27FC236}">
-                <a16:creationId xmlns:a16="http://schemas.microsoft.com/office/drawing/2014/main" id="{72407F36-C44A-4382-AAD4-832D6ADE80CA}"/>
+                <a16:creationId xmlns:a16="http://schemas.microsoft.com/office/drawing/2014/main" id="{C8FD9135-5304-4160-85DE-BC664F8312E2}"/>
               </a:ext>
             </a:extLst>
           </p:cNvPr>
@@ -5593,7 +5593,7 @@
           <p:cNvPr id="14" name="Rounded Rectangle 13">
             <a:extLst xmlns:a="http://schemas.openxmlformats.org/drawingml/2006/main">
               <a:ext uri="{FF2B5EF4-FFF2-40B4-BE49-F238E27FC236}">
-                <a16:creationId xmlns:a16="http://schemas.microsoft.com/office/drawing/2014/main" id="{AD7F23ED-2069-4BD4-9320-1FB8E1FEB3D2}"/>
+                <a16:creationId xmlns:a16="http://schemas.microsoft.com/office/drawing/2014/main" id="{D3FAC365-CB3C-40B5-83B3-569F3198460A}"/>
               </a:ext>
             </a:extLst>
           </p:cNvPr>
@@ -5648,7 +5648,7 @@
           <p:cNvPr id="15" name="TextBox 14">
             <a:extLst xmlns:a="http://schemas.openxmlformats.org/drawingml/2006/main">
               <a:ext uri="{FF2B5EF4-FFF2-40B4-BE49-F238E27FC236}">
-                <a16:creationId xmlns:a16="http://schemas.microsoft.com/office/drawing/2014/main" id="{D361B61A-BD67-4057-B680-DEDBF1DB1264}"/>
+                <a16:creationId xmlns:a16="http://schemas.microsoft.com/office/drawing/2014/main" id="{D71B3AC4-8C91-4202-B37A-413F9F5E0097}"/>
               </a:ext>
             </a:extLst>
           </p:cNvPr>
@@ -5717,7 +5717,7 @@
           <p:cNvPr id="16" name="Connector 15">
             <a:extLst xmlns:a="http://schemas.openxmlformats.org/drawingml/2006/main">
               <a:ext uri="{FF2B5EF4-FFF2-40B4-BE49-F238E27FC236}">
-                <a16:creationId xmlns:a16="http://schemas.microsoft.com/office/drawing/2014/main" id="{BA7C7AD2-37C0-489D-8BA4-1BBBF25D50E1}"/>
+                <a16:creationId xmlns:a16="http://schemas.microsoft.com/office/drawing/2014/main" id="{4C06F79D-CE35-442D-A64D-D8300893F926}"/>
               </a:ext>
             </a:extLst>
           </p:cNvPr>
@@ -5760,7 +5760,7 @@
           <p:cNvPr id="17" name="Rounded Rectangle 16">
             <a:extLst xmlns:a="http://schemas.openxmlformats.org/drawingml/2006/main">
               <a:ext uri="{FF2B5EF4-FFF2-40B4-BE49-F238E27FC236}">
-                <a16:creationId xmlns:a16="http://schemas.microsoft.com/office/drawing/2014/main" id="{E4DB78D3-973D-4DA9-89FD-068A16C9EC8C}"/>
+                <a16:creationId xmlns:a16="http://schemas.microsoft.com/office/drawing/2014/main" id="{3BA4FA40-9A45-4689-9A68-C7D2C066692D}"/>
               </a:ext>
             </a:extLst>
           </p:cNvPr>
@@ -5815,7 +5815,7 @@
           <p:cNvPr id="18" name="TextBox 17">
             <a:extLst xmlns:a="http://schemas.openxmlformats.org/drawingml/2006/main">
               <a:ext uri="{FF2B5EF4-FFF2-40B4-BE49-F238E27FC236}">
-                <a16:creationId xmlns:a16="http://schemas.microsoft.com/office/drawing/2014/main" id="{CA89159C-5A29-4D43-A7BF-F4AEF5DA0535}"/>
+                <a16:creationId xmlns:a16="http://schemas.microsoft.com/office/drawing/2014/main" id="{8875588F-00BD-4580-8950-8FA6CFB519E3}"/>
               </a:ext>
             </a:extLst>
           </p:cNvPr>
@@ -5884,7 +5884,7 @@
           <p:cNvPr id="19" name="TextBox 18">
             <a:extLst xmlns:a="http://schemas.openxmlformats.org/drawingml/2006/main">
               <a:ext uri="{FF2B5EF4-FFF2-40B4-BE49-F238E27FC236}">
-                <a16:creationId xmlns:a16="http://schemas.microsoft.com/office/drawing/2014/main" id="{7FCFD672-4A4D-4FFE-955B-6F747C30E3C4}"/>
+                <a16:creationId xmlns:a16="http://schemas.microsoft.com/office/drawing/2014/main" id="{30225AB3-31A9-4E22-A95D-9C62B31C870B}"/>
               </a:ext>
             </a:extLst>
           </p:cNvPr>
@@ -5934,7 +5934,7 @@
           <p:cNvPr id="20" name="TextBox 19">
             <a:extLst xmlns:a="http://schemas.openxmlformats.org/drawingml/2006/main">
               <a:ext uri="{FF2B5EF4-FFF2-40B4-BE49-F238E27FC236}">
-                <a16:creationId xmlns:a16="http://schemas.microsoft.com/office/drawing/2014/main" id="{6FA20288-6959-4F2E-9AE9-0118AF488C65}"/>
+                <a16:creationId xmlns:a16="http://schemas.microsoft.com/office/drawing/2014/main" id="{4073D09C-773F-4D59-8573-D3B673CBC2FA}"/>
               </a:ext>
             </a:extLst>
           </p:cNvPr>
@@ -5982,7 +5982,7 @@
     </p:spTree>
     <p:extLst>
       <p:ext uri="{BB962C8B-B14F-4D97-AF65-F5344CB8AC3E}">
-        <p14:creationId xmlns:p14="http://schemas.microsoft.com/office/powerpoint/2010/main" val="1906725283"/>
+        <p14:creationId xmlns:p14="http://schemas.microsoft.com/office/powerpoint/2010/main" val="1601137909"/>
       </p:ext>
     </p:extLst>
   </p:cSld>
@@ -6013,7 +6013,7 @@
           <p:cNvPr id="2" name="TextBox 1">
             <a:extLst xmlns:a="http://schemas.openxmlformats.org/drawingml/2006/main">
               <a:ext uri="{FF2B5EF4-FFF2-40B4-BE49-F238E27FC236}">
-                <a16:creationId xmlns:a16="http://schemas.microsoft.com/office/drawing/2014/main" id="{E9A93947-894A-4519-83B7-004E0F80D31B}"/>
+                <a16:creationId xmlns:a16="http://schemas.microsoft.com/office/drawing/2014/main" id="{2EFD9694-3243-4A09-BFCB-35D2917AEF7E}"/>
               </a:ext>
             </a:extLst>
           </p:cNvPr>
@@ -6063,7 +6063,7 @@
           <p:cNvPr id="3" name="TextBox 2">
             <a:extLst xmlns:a="http://schemas.openxmlformats.org/drawingml/2006/main">
               <a:ext uri="{FF2B5EF4-FFF2-40B4-BE49-F238E27FC236}">
-                <a16:creationId xmlns:a16="http://schemas.microsoft.com/office/drawing/2014/main" id="{75DE43A5-08D0-4E9C-B599-B781FE42B824}"/>
+                <a16:creationId xmlns:a16="http://schemas.microsoft.com/office/drawing/2014/main" id="{F21C62C6-01CA-4487-B7FA-5A948D0EAA58}"/>
               </a:ext>
             </a:extLst>
           </p:cNvPr>
@@ -6113,7 +6113,7 @@
           <p:cNvPr id="4" name="TextBox 3">
             <a:extLst xmlns:a="http://schemas.openxmlformats.org/drawingml/2006/main">
               <a:ext uri="{FF2B5EF4-FFF2-40B4-BE49-F238E27FC236}">
-                <a16:creationId xmlns:a16="http://schemas.microsoft.com/office/drawing/2014/main" id="{4AE83F04-FE6C-4946-A9D4-4413F80A34D0}"/>
+                <a16:creationId xmlns:a16="http://schemas.microsoft.com/office/drawing/2014/main" id="{7B6B2740-DC71-47A6-B1E7-CA5FE251594B}"/>
               </a:ext>
             </a:extLst>
           </p:cNvPr>
@@ -6163,7 +6163,7 @@
           <p:cNvPr id="5" name="Table 4">
             <a:extLst xmlns:a="http://schemas.openxmlformats.org/drawingml/2006/main">
               <a:ext uri="{FF2B5EF4-FFF2-40B4-BE49-F238E27FC236}">
-                <a16:creationId xmlns:a16="http://schemas.microsoft.com/office/drawing/2014/main" id="{0A4DFF2B-3383-42AA-8059-6D7CCAECF3B6}"/>
+                <a16:creationId xmlns:a16="http://schemas.microsoft.com/office/drawing/2014/main" id="{9D0BBC85-FD5F-455C-B6B9-0D1CC93AE999}"/>
               </a:ext>
             </a:extLst>
           </p:cNvPr>
@@ -6527,7 +6527,7 @@
     </p:spTree>
     <p:extLst>
       <p:ext uri="{BB962C8B-B14F-4D97-AF65-F5344CB8AC3E}">
-        <p14:creationId xmlns:p14="http://schemas.microsoft.com/office/powerpoint/2010/main" val="1610429992"/>
+        <p14:creationId xmlns:p14="http://schemas.microsoft.com/office/powerpoint/2010/main" val="95435302"/>
       </p:ext>
     </p:extLst>
   </p:cSld>
@@ -6558,7 +6558,7 @@
           <p:cNvPr id="2" name="TextBox 1">
             <a:extLst xmlns:a="http://schemas.openxmlformats.org/drawingml/2006/main">
               <a:ext uri="{FF2B5EF4-FFF2-40B4-BE49-F238E27FC236}">
-                <a16:creationId xmlns:a16="http://schemas.microsoft.com/office/drawing/2014/main" id="{9D6E3475-8AAB-4808-864F-8604011EF688}"/>
+                <a16:creationId xmlns:a16="http://schemas.microsoft.com/office/drawing/2014/main" id="{662E87AB-7408-466C-9BEE-8FDB933863C2}"/>
               </a:ext>
             </a:extLst>
           </p:cNvPr>
@@ -6608,7 +6608,7 @@
           <p:cNvPr id="3" name="TextBox 2">
             <a:extLst xmlns:a="http://schemas.openxmlformats.org/drawingml/2006/main">
               <a:ext uri="{FF2B5EF4-FFF2-40B4-BE49-F238E27FC236}">
-                <a16:creationId xmlns:a16="http://schemas.microsoft.com/office/drawing/2014/main" id="{1CE30B25-2F62-4F8B-B132-02393FC2CF15}"/>
+                <a16:creationId xmlns:a16="http://schemas.microsoft.com/office/drawing/2014/main" id="{CEB9997C-ABE6-48FD-BA06-770AE5C84B47}"/>
               </a:ext>
             </a:extLst>
           </p:cNvPr>
@@ -6658,7 +6658,7 @@
           <p:cNvPr id="4" name="TextBox 3">
             <a:extLst xmlns:a="http://schemas.openxmlformats.org/drawingml/2006/main">
               <a:ext uri="{FF2B5EF4-FFF2-40B4-BE49-F238E27FC236}">
-                <a16:creationId xmlns:a16="http://schemas.microsoft.com/office/drawing/2014/main" id="{DAEEB791-CD8B-4776-B5F0-E91ABE68E1CE}"/>
+                <a16:creationId xmlns:a16="http://schemas.microsoft.com/office/drawing/2014/main" id="{87A2714A-F61F-473A-AE4D-432C8FCF213B}"/>
               </a:ext>
             </a:extLst>
           </p:cNvPr>
@@ -6708,7 +6708,7 @@
           <p:cNvPr id="5" name="TextBox 4">
             <a:extLst xmlns:a="http://schemas.openxmlformats.org/drawingml/2006/main">
               <a:ext uri="{FF2B5EF4-FFF2-40B4-BE49-F238E27FC236}">
-                <a16:creationId xmlns:a16="http://schemas.microsoft.com/office/drawing/2014/main" id="{B887CFE9-DB49-4718-980D-55FF8D6E4DCC}"/>
+                <a16:creationId xmlns:a16="http://schemas.microsoft.com/office/drawing/2014/main" id="{92DFE098-C2E9-434C-9048-828AA9F89140}"/>
               </a:ext>
             </a:extLst>
           </p:cNvPr>
@@ -6758,7 +6758,7 @@
           <p:cNvPr id="6" name="TextBox 5">
             <a:extLst xmlns:a="http://schemas.openxmlformats.org/drawingml/2006/main">
               <a:ext uri="{FF2B5EF4-FFF2-40B4-BE49-F238E27FC236}">
-                <a16:creationId xmlns:a16="http://schemas.microsoft.com/office/drawing/2014/main" id="{0330B063-9B59-415A-A39B-A8711E54EAC7}"/>
+                <a16:creationId xmlns:a16="http://schemas.microsoft.com/office/drawing/2014/main" id="{AB5BFF6E-13D2-489A-A834-6CE7E0F7173A}"/>
               </a:ext>
             </a:extLst>
           </p:cNvPr>
@@ -6806,7 +6806,7 @@
     </p:spTree>
     <p:extLst>
       <p:ext uri="{BB962C8B-B14F-4D97-AF65-F5344CB8AC3E}">
-        <p14:creationId xmlns:p14="http://schemas.microsoft.com/office/powerpoint/2010/main" val="939284530"/>
+        <p14:creationId xmlns:p14="http://schemas.microsoft.com/office/powerpoint/2010/main" val="210663340"/>
       </p:ext>
     </p:extLst>
   </p:cSld>
@@ -6837,7 +6837,7 @@
           <p:cNvPr id="2" name="TextBox 1">
             <a:extLst xmlns:a="http://schemas.openxmlformats.org/drawingml/2006/main">
               <a:ext uri="{FF2B5EF4-FFF2-40B4-BE49-F238E27FC236}">
-                <a16:creationId xmlns:a16="http://schemas.microsoft.com/office/drawing/2014/main" id="{6F31CBC2-C1BC-44DB-8769-DF7CB88E237F}"/>
+                <a16:creationId xmlns:a16="http://schemas.microsoft.com/office/drawing/2014/main" id="{949A956D-549E-4CB6-A226-136FBC1EDDBC}"/>
               </a:ext>
             </a:extLst>
           </p:cNvPr>
@@ -6887,7 +6887,7 @@
           <p:cNvPr id="3" name="TextBox 2">
             <a:extLst xmlns:a="http://schemas.openxmlformats.org/drawingml/2006/main">
               <a:ext uri="{FF2B5EF4-FFF2-40B4-BE49-F238E27FC236}">
-                <a16:creationId xmlns:a16="http://schemas.microsoft.com/office/drawing/2014/main" id="{EE74BEE3-93A6-4C43-9120-65ADBB17BD56}"/>
+                <a16:creationId xmlns:a16="http://schemas.microsoft.com/office/drawing/2014/main" id="{C186AA0B-577F-47EC-904D-3E41025C98EA}"/>
               </a:ext>
             </a:extLst>
           </p:cNvPr>
@@ -6937,7 +6937,7 @@
           <p:cNvPr id="4" name="TextBox 3">
             <a:extLst xmlns:a="http://schemas.openxmlformats.org/drawingml/2006/main">
               <a:ext uri="{FF2B5EF4-FFF2-40B4-BE49-F238E27FC236}">
-                <a16:creationId xmlns:a16="http://schemas.microsoft.com/office/drawing/2014/main" id="{35BF3521-8488-4932-8489-BC8671D2FD38}"/>
+                <a16:creationId xmlns:a16="http://schemas.microsoft.com/office/drawing/2014/main" id="{B50CF43E-A994-41A7-A54D-9D2BD5EC4AF1}"/>
               </a:ext>
             </a:extLst>
           </p:cNvPr>
@@ -6987,7 +6987,7 @@
           <p:cNvPr id="5" name="Table 4">
             <a:extLst xmlns:a="http://schemas.openxmlformats.org/drawingml/2006/main">
               <a:ext uri="{FF2B5EF4-FFF2-40B4-BE49-F238E27FC236}">
-                <a16:creationId xmlns:a16="http://schemas.microsoft.com/office/drawing/2014/main" id="{D2393264-A9E9-4C95-81DE-668E51AFA8A8}"/>
+                <a16:creationId xmlns:a16="http://schemas.microsoft.com/office/drawing/2014/main" id="{2EA12794-9129-4DD9-AA3B-C48C2258A05F}"/>
               </a:ext>
             </a:extLst>
           </p:cNvPr>
@@ -7138,7 +7138,7 @@
                           <a:ea typeface="Aptos"/>
                           <a:cs typeface="Aptos"/>
                         </a:rPr>
-                        <a:t>Historical real Ollama calls</a:t>
+                        <a:t>Current real Groq boundaries</a:t>
                       </a:r>
                     </a:p>
                   </a:txBody>
@@ -7165,7 +7165,7 @@
                           <a:ea typeface="Aptos"/>
                           <a:cs typeface="Aptos"/>
                         </a:rPr>
-                        <a:t>37 calls; 10/10 boundary checks</a:t>
+                        <a:t>8/8 checks; 4 actual model calls</a:t>
                       </a:r>
                     </a:p>
                   </a:txBody>
@@ -7297,7 +7297,7 @@
           <p:cNvPr id="6" name="TextBox 5">
             <a:extLst xmlns:a="http://schemas.openxmlformats.org/drawingml/2006/main">
               <a:ext uri="{FF2B5EF4-FFF2-40B4-BE49-F238E27FC236}">
-                <a16:creationId xmlns:a16="http://schemas.microsoft.com/office/drawing/2014/main" id="{DCB753DC-FCB8-4B93-B7A9-EFFBFC8B28D3}"/>
+                <a16:creationId xmlns:a16="http://schemas.microsoft.com/office/drawing/2014/main" id="{82135FDA-9A95-458F-BA58-8D6C7B97F38B}"/>
               </a:ext>
             </a:extLst>
           </p:cNvPr>
@@ -7345,7 +7345,7 @@
     </p:spTree>
     <p:extLst>
       <p:ext uri="{BB962C8B-B14F-4D97-AF65-F5344CB8AC3E}">
-        <p14:creationId xmlns:p14="http://schemas.microsoft.com/office/powerpoint/2010/main" val="300406259"/>
+        <p14:creationId xmlns:p14="http://schemas.microsoft.com/office/powerpoint/2010/main" val="767158856"/>
       </p:ext>
     </p:extLst>
   </p:cSld>
@@ -7376,7 +7376,7 @@
           <p:cNvPr id="2" name="TextBox 1">
             <a:extLst xmlns:a="http://schemas.openxmlformats.org/drawingml/2006/main">
               <a:ext uri="{FF2B5EF4-FFF2-40B4-BE49-F238E27FC236}">
-                <a16:creationId xmlns:a16="http://schemas.microsoft.com/office/drawing/2014/main" id="{33688189-AD05-4A6B-BF0B-9561B54FEA99}"/>
+                <a16:creationId xmlns:a16="http://schemas.microsoft.com/office/drawing/2014/main" id="{B57434A9-D8F3-4918-A81E-256492663A2D}"/>
               </a:ext>
             </a:extLst>
           </p:cNvPr>
@@ -7426,7 +7426,7 @@
           <p:cNvPr id="3" name="TextBox 2">
             <a:extLst xmlns:a="http://schemas.openxmlformats.org/drawingml/2006/main">
               <a:ext uri="{FF2B5EF4-FFF2-40B4-BE49-F238E27FC236}">
-                <a16:creationId xmlns:a16="http://schemas.microsoft.com/office/drawing/2014/main" id="{101662C5-3A5A-4F41-81B1-A5DA5131E7EF}"/>
+                <a16:creationId xmlns:a16="http://schemas.microsoft.com/office/drawing/2014/main" id="{6B0A1CB5-2FEC-4FBA-89C7-93B7781EEF94}"/>
               </a:ext>
             </a:extLst>
           </p:cNvPr>
@@ -7476,7 +7476,7 @@
           <p:cNvPr id="4" name="TextBox 3">
             <a:extLst xmlns:a="http://schemas.openxmlformats.org/drawingml/2006/main">
               <a:ext uri="{FF2B5EF4-FFF2-40B4-BE49-F238E27FC236}">
-                <a16:creationId xmlns:a16="http://schemas.microsoft.com/office/drawing/2014/main" id="{DC009453-FD63-4286-BE3B-198B04511640}"/>
+                <a16:creationId xmlns:a16="http://schemas.microsoft.com/office/drawing/2014/main" id="{04D9F907-0FF5-4C57-90F2-BF6FDC732973}"/>
               </a:ext>
             </a:extLst>
           </p:cNvPr>
@@ -7526,7 +7526,7 @@
           <p:cNvPr id="5" name="Table 4">
             <a:extLst xmlns:a="http://schemas.openxmlformats.org/drawingml/2006/main">
               <a:ext uri="{FF2B5EF4-FFF2-40B4-BE49-F238E27FC236}">
-                <a16:creationId xmlns:a16="http://schemas.microsoft.com/office/drawing/2014/main" id="{25B66EED-7A3A-48FD-A3FF-EE37D71FA1AB}"/>
+                <a16:creationId xmlns:a16="http://schemas.microsoft.com/office/drawing/2014/main" id="{B20D4CB2-4E47-406C-B8A6-D1EFBA7DE47E}"/>
               </a:ext>
             </a:extLst>
           </p:cNvPr>
@@ -7806,7 +7806,7 @@
           <p:cNvPr id="6" name="TextBox 5">
             <a:extLst xmlns:a="http://schemas.openxmlformats.org/drawingml/2006/main">
               <a:ext uri="{FF2B5EF4-FFF2-40B4-BE49-F238E27FC236}">
-                <a16:creationId xmlns:a16="http://schemas.microsoft.com/office/drawing/2014/main" id="{7E644D03-92F3-40CA-B2AF-A0DF9B4E31A2}"/>
+                <a16:creationId xmlns:a16="http://schemas.microsoft.com/office/drawing/2014/main" id="{4DE53B42-E97E-434A-BC1D-70EC3089B5DE}"/>
               </a:ext>
             </a:extLst>
           </p:cNvPr>
@@ -7856,7 +7856,7 @@
           <p:cNvPr id="7" name="TextBox 6">
             <a:extLst xmlns:a="http://schemas.openxmlformats.org/drawingml/2006/main">
               <a:ext uri="{FF2B5EF4-FFF2-40B4-BE49-F238E27FC236}">
-                <a16:creationId xmlns:a16="http://schemas.microsoft.com/office/drawing/2014/main" id="{A0FF6057-32C6-43C6-AF96-FF4CE1108A40}"/>
+                <a16:creationId xmlns:a16="http://schemas.microsoft.com/office/drawing/2014/main" id="{030F5287-F9AE-431E-8D9A-D9261C28C10C}"/>
               </a:ext>
             </a:extLst>
           </p:cNvPr>
@@ -7904,7 +7904,7 @@
     </p:spTree>
     <p:extLst>
       <p:ext uri="{BB962C8B-B14F-4D97-AF65-F5344CB8AC3E}">
-        <p14:creationId xmlns:p14="http://schemas.microsoft.com/office/powerpoint/2010/main" val="189944154"/>
+        <p14:creationId xmlns:p14="http://schemas.microsoft.com/office/powerpoint/2010/main" val="964035120"/>
       </p:ext>
     </p:extLst>
   </p:cSld>
@@ -7935,7 +7935,7 @@
           <p:cNvPr id="2" name="TextBox 1">
             <a:extLst xmlns:a="http://schemas.openxmlformats.org/drawingml/2006/main">
               <a:ext uri="{FF2B5EF4-FFF2-40B4-BE49-F238E27FC236}">
-                <a16:creationId xmlns:a16="http://schemas.microsoft.com/office/drawing/2014/main" id="{B7F91D5D-8906-41BE-A670-10B72DF97AAD}"/>
+                <a16:creationId xmlns:a16="http://schemas.microsoft.com/office/drawing/2014/main" id="{389B8768-3EA8-4927-A69D-D55694F0C344}"/>
               </a:ext>
             </a:extLst>
           </p:cNvPr>
@@ -7985,7 +7985,7 @@
           <p:cNvPr id="3" name="TextBox 2">
             <a:extLst xmlns:a="http://schemas.openxmlformats.org/drawingml/2006/main">
               <a:ext uri="{FF2B5EF4-FFF2-40B4-BE49-F238E27FC236}">
-                <a16:creationId xmlns:a16="http://schemas.microsoft.com/office/drawing/2014/main" id="{D7F55F1C-B910-458B-A7A0-09D36AD82903}"/>
+                <a16:creationId xmlns:a16="http://schemas.microsoft.com/office/drawing/2014/main" id="{49772A06-6DD5-4C54-A6B2-F32B820FACC1}"/>
               </a:ext>
             </a:extLst>
           </p:cNvPr>
@@ -8035,7 +8035,7 @@
           <p:cNvPr id="4" name="TextBox 3">
             <a:extLst xmlns:a="http://schemas.openxmlformats.org/drawingml/2006/main">
               <a:ext uri="{FF2B5EF4-FFF2-40B4-BE49-F238E27FC236}">
-                <a16:creationId xmlns:a16="http://schemas.microsoft.com/office/drawing/2014/main" id="{8BFF7546-359B-494B-B1E5-D85965DBECE1}"/>
+                <a16:creationId xmlns:a16="http://schemas.microsoft.com/office/drawing/2014/main" id="{093A9E0C-7B91-4A7A-8DBF-10C38C1063EF}"/>
               </a:ext>
             </a:extLst>
           </p:cNvPr>
@@ -8085,7 +8085,7 @@
           <p:cNvPr id="5" name="Table 4">
             <a:extLst xmlns:a="http://schemas.openxmlformats.org/drawingml/2006/main">
               <a:ext uri="{FF2B5EF4-FFF2-40B4-BE49-F238E27FC236}">
-                <a16:creationId xmlns:a16="http://schemas.microsoft.com/office/drawing/2014/main" id="{00A02F53-2405-40F2-B351-29F9D6106AA0}"/>
+                <a16:creationId xmlns:a16="http://schemas.microsoft.com/office/drawing/2014/main" id="{C1AFF868-CC1F-45DF-A1EE-EA9A26788192}"/>
               </a:ext>
             </a:extLst>
           </p:cNvPr>
@@ -8395,7 +8395,7 @@
           <p:cNvPr id="6" name="TextBox 5">
             <a:extLst xmlns:a="http://schemas.openxmlformats.org/drawingml/2006/main">
               <a:ext uri="{FF2B5EF4-FFF2-40B4-BE49-F238E27FC236}">
-                <a16:creationId xmlns:a16="http://schemas.microsoft.com/office/drawing/2014/main" id="{620894D5-AD34-497D-BDD7-E93B2BEA3A03}"/>
+                <a16:creationId xmlns:a16="http://schemas.microsoft.com/office/drawing/2014/main" id="{D27E0796-8598-4A94-A0A6-68C7017970A6}"/>
               </a:ext>
             </a:extLst>
           </p:cNvPr>
@@ -8443,7 +8443,7 @@
     </p:spTree>
     <p:extLst>
       <p:ext uri="{BB962C8B-B14F-4D97-AF65-F5344CB8AC3E}">
-        <p14:creationId xmlns:p14="http://schemas.microsoft.com/office/powerpoint/2010/main" val="1703100413"/>
+        <p14:creationId xmlns:p14="http://schemas.microsoft.com/office/powerpoint/2010/main" val="918522436"/>
       </p:ext>
     </p:extLst>
   </p:cSld>
@@ -8474,7 +8474,7 @@
           <p:cNvPr id="2" name="TextBox 1">
             <a:extLst xmlns:a="http://schemas.openxmlformats.org/drawingml/2006/main">
               <a:ext uri="{FF2B5EF4-FFF2-40B4-BE49-F238E27FC236}">
-                <a16:creationId xmlns:a16="http://schemas.microsoft.com/office/drawing/2014/main" id="{9A3634C4-A03E-44BA-A421-9B29DDAF0BC6}"/>
+                <a16:creationId xmlns:a16="http://schemas.microsoft.com/office/drawing/2014/main" id="{9AF21FE4-F8DE-4C59-A091-C1C7C50ED14D}"/>
               </a:ext>
             </a:extLst>
           </p:cNvPr>
@@ -8524,7 +8524,7 @@
           <p:cNvPr id="3" name="TextBox 2">
             <a:extLst xmlns:a="http://schemas.openxmlformats.org/drawingml/2006/main">
               <a:ext uri="{FF2B5EF4-FFF2-40B4-BE49-F238E27FC236}">
-                <a16:creationId xmlns:a16="http://schemas.microsoft.com/office/drawing/2014/main" id="{E0912F78-23EF-4B39-9BF0-91099737CCAE}"/>
+                <a16:creationId xmlns:a16="http://schemas.microsoft.com/office/drawing/2014/main" id="{1C9086D1-9D07-4FD3-AD37-34F09150E0B2}"/>
               </a:ext>
             </a:extLst>
           </p:cNvPr>
@@ -8574,7 +8574,7 @@
           <p:cNvPr id="4" name="TextBox 3">
             <a:extLst xmlns:a="http://schemas.openxmlformats.org/drawingml/2006/main">
               <a:ext uri="{FF2B5EF4-FFF2-40B4-BE49-F238E27FC236}">
-                <a16:creationId xmlns:a16="http://schemas.microsoft.com/office/drawing/2014/main" id="{907E8EE3-86B3-4506-B001-FCD8DA955884}"/>
+                <a16:creationId xmlns:a16="http://schemas.microsoft.com/office/drawing/2014/main" id="{322BE2FA-D0D3-43DD-8310-3E7C6DC0CBE0}"/>
               </a:ext>
             </a:extLst>
           </p:cNvPr>
@@ -8624,7 +8624,7 @@
           <p:cNvPr id="5" name="TextBox 4">
             <a:extLst xmlns:a="http://schemas.openxmlformats.org/drawingml/2006/main">
               <a:ext uri="{FF2B5EF4-FFF2-40B4-BE49-F238E27FC236}">
-                <a16:creationId xmlns:a16="http://schemas.microsoft.com/office/drawing/2014/main" id="{94F7350C-A9B7-4CD8-9256-6C5B6EA16F4E}"/>
+                <a16:creationId xmlns:a16="http://schemas.microsoft.com/office/drawing/2014/main" id="{2CA2E536-D1FF-42EB-B2F0-D92169515C3D}"/>
               </a:ext>
             </a:extLst>
           </p:cNvPr>
@@ -8674,7 +8674,7 @@
           <p:cNvPr id="6" name="TextBox 5">
             <a:extLst xmlns:a="http://schemas.openxmlformats.org/drawingml/2006/main">
               <a:ext uri="{FF2B5EF4-FFF2-40B4-BE49-F238E27FC236}">
-                <a16:creationId xmlns:a16="http://schemas.microsoft.com/office/drawing/2014/main" id="{25110A92-D13A-425F-90F6-888B957B5540}"/>
+                <a16:creationId xmlns:a16="http://schemas.microsoft.com/office/drawing/2014/main" id="{09B87BBA-71F6-485B-A5A3-1C4073367B54}"/>
               </a:ext>
             </a:extLst>
           </p:cNvPr>
@@ -8722,7 +8722,7 @@
     </p:spTree>
     <p:extLst>
       <p:ext uri="{BB962C8B-B14F-4D97-AF65-F5344CB8AC3E}">
-        <p14:creationId xmlns:p14="http://schemas.microsoft.com/office/powerpoint/2010/main" val="330748666"/>
+        <p14:creationId xmlns:p14="http://schemas.microsoft.com/office/powerpoint/2010/main" val="1289584261"/>
       </p:ext>
     </p:extLst>
   </p:cSld>

</xml_diff>